<commit_message>
update: align target batch year to 2027 passing out across web app, database, docs, and PowerPoint deck
</commit_message>
<xml_diff>
--- a/NxtWave_Growth_Challenge_5_Slide_Deck.pptx
+++ b/NxtWave_Growth_Challenge_5_Slide_Deck.pptx
@@ -3254,7 +3254,7 @@
               </a:defRPr>
             </a:pPr>
             <a:r>
-              <a:t>Target: 500 Final-Year Engineers (Batch 2025/2026) | 7-Day Sprint | Budget: ₹2,000</a:t>
+              <a:t>Target: 500 Engineering Students (2027 Passing Out) | 7-Day Sprint | Budget: ₹2,000</a:t>
             </a:r>
           </a:p>
         </p:txBody>
@@ -3320,11 +3320,11 @@
               </a:defRPr>
             </a:pPr>
             <a:r>
-              <a:t>• Final-year engineering students across CSE, IT, ECE, EEE, Mechanical &amp; Civil.</a:t>
+              <a:t>• Engineering students across CSE, IT, ECE, EEE, Mechanical &amp; Civil (2027 Passing Out).</a:t>
             </a:r>
             <a:br/>
             <a:r>
-              <a:t>• Currently preparing for on-campus &amp; off-campus placement drives.</a:t>
+              <a:t>• Currently preparing for upcoming on-campus &amp; off-campus placement drives.</a:t>
             </a:r>
             <a:br/>
             <a:r>

</xml_diff>